<commit_message>
Update the deck and the spec to match what now exists
The deck's feasibility numbers now carry the trained model: 1,09,116
road-days of real recorded weather, held-out accuracy 0.88, four apps.

SUKOBIN_ALGORITHM.md section 12.4 no longer says the officer app is unbuilt,
and section 17 is rewritten against what is actually verified. It states the
one caveat plainly: the historical labels are drawn from a rainfall-threshold
hazard function because no machine-readable closure log exists for these
stretches, so the model must not be described as trained on observed closures.
</commit_message>
<xml_diff>
--- a/SIH2026_Sukobin.pptx
+++ b/SIH2026_Sukobin.pptx
@@ -4649,7 +4649,7 @@
             </a:pPr>
             <a:r>
               <a:rPr sz="950" b="0"/>
-              <a:t>district map and alerts</a:t>
+              <a:t>weak points and forecast</a:t>
             </a:r>
           </a:p>
         </p:txBody>
@@ -4695,7 +4695,7 @@
             </a:pPr>
             <a:r>
               <a:rPr sz="1100" b="1"/>
-              <a:t>Notifications</a:t>
+              <a:t>Alerts</a:t>
             </a:r>
           </a:p>
           <a:p>
@@ -4706,7 +4706,7 @@
             </a:pPr>
             <a:r>
               <a:rPr sz="950" b="0"/>
-              <a:t>drivers, officers, customers</a:t>
+              <a:t>sent in the reader's own language</a:t>
             </a:r>
           </a:p>
         </p:txBody>
@@ -4875,7 +4875,7 @@
             </a:pPr>
             <a:r>
               <a:rPr sz="1100" b="0"/>
-              <a:t>Android apps in Kotlin and XML</a:t>
+              <a:t>Four Android apps in Kotlin and XML</a:t>
             </a:r>
           </a:p>
           <a:p>
@@ -4897,6 +4897,17 @@
             </a:pPr>
             <a:r>
               <a:rPr sz="1100" b="0"/>
+              <a:t>A model trained in plain JavaScript, no add-ons needed</a:t>
+            </a:r>
+          </a:p>
+          <a:p>
+            <a:pPr algn="l">
+              <a:spcAft>
+                <a:spcPts val="600"/>
+              </a:spcAft>
+            </a:pPr>
+            <a:r>
+              <a:rPr sz="1100" b="0"/>
               <a:t>OSRM for real road routes</a:t>
             </a:r>
           </a:p>
@@ -4920,17 +4931,6 @@
             <a:r>
               <a:rPr sz="1100" b="0"/>
               <a:t>React and MapLibre for the dashboard</a:t>
-            </a:r>
-          </a:p>
-          <a:p>
-            <a:pPr algn="l">
-              <a:spcAft>
-                <a:spcPts val="600"/>
-              </a:spcAft>
-            </a:pPr>
-            <a:r>
-              <a:rPr sz="1100" b="0"/>
-              <a:t>Firebase for notifications</a:t>
             </a:r>
           </a:p>
         </p:txBody>
@@ -5025,7 +5025,7 @@
         </p:nvGraphicFramePr>
         <p:xfrm>
           <a:off x="822960" y="1417320"/>
-          <a:ext cx="10607040" cy="658368"/>
+          <a:ext cx="10607040" cy="731520"/>
         </p:xfrm>
         <a:graphic>
           <a:graphicData uri="http://schemas.openxmlformats.org/drawingml/2006/table">
@@ -5035,12 +5035,12 @@
               </a:tblPr>
               <a:tblGrid>
                 <a:gridCol w="2103120"/>
-                <a:gridCol w="2103120"/>
-                <a:gridCol w="2103120"/>
-                <a:gridCol w="2194560"/>
-                <a:gridCol w="2103120"/>
+                <a:gridCol w="1737360"/>
+                <a:gridCol w="2834640"/>
+                <a:gridCol w="2011680"/>
+                <a:gridCol w="1920240"/>
               </a:tblGrid>
-              <a:tr h="329184">
+              <a:tr h="365760">
                 <a:tc>
                   <a:txBody>
                     <a:bodyPr/>
@@ -5052,7 +5052,7 @@
                         </a:spcAft>
                       </a:pPr>
                       <a:r>
-                        <a:rPr sz="1150"/>
+                        <a:rPr sz="1100"/>
                         <a:t>Roads modelled</a:t>
                       </a:r>
                     </a:p>
@@ -5070,7 +5070,7 @@
                         </a:spcAft>
                       </a:pPr>
                       <a:r>
-                        <a:rPr sz="1150"/>
+                        <a:rPr sz="1100"/>
                         <a:t>Length covered</a:t>
                       </a:r>
                     </a:p>
@@ -5088,8 +5088,8 @@
                         </a:spcAft>
                       </a:pPr>
                       <a:r>
-                        <a:rPr sz="1150"/>
-                        <a:t>Districts</a:t>
+                        <a:rPr sz="1100"/>
+                        <a:t>Model trained on</a:t>
                       </a:r>
                     </a:p>
                   </a:txBody>
@@ -5106,8 +5106,8 @@
                         </a:spcAft>
                       </a:pPr>
                       <a:r>
-                        <a:rPr sz="1150"/>
-                        <a:t>Weak points found</a:t>
+                        <a:rPr sz="1100"/>
+                        <a:t>Forecast accuracy</a:t>
                       </a:r>
                     </a:p>
                   </a:txBody>
@@ -5124,15 +5124,15 @@
                         </a:spcAft>
                       </a:pPr>
                       <a:r>
-                        <a:rPr sz="1150"/>
-                        <a:t>Apps built</a:t>
+                        <a:rPr sz="1100"/>
+                        <a:t>Built</a:t>
                       </a:r>
                     </a:p>
                   </a:txBody>
                   <a:tcPr marL="73152" marR="73152" marT="18288" marB="18288"/>
                 </a:tc>
               </a:tr>
-              <a:tr h="329184">
+              <a:tr h="365760">
                 <a:tc>
                   <a:txBody>
                     <a:bodyPr/>
@@ -5144,8 +5144,8 @@
                         </a:spcAft>
                       </a:pPr>
                       <a:r>
-                        <a:rPr sz="1150"/>
-                        <a:t>42 sections</a:t>
+                        <a:rPr sz="1100"/>
+                        <a:t>42 sections, 82 districts</a:t>
                       </a:r>
                     </a:p>
                   </a:txBody>
@@ -5162,7 +5162,7 @@
                         </a:spcAft>
                       </a:pPr>
                       <a:r>
-                        <a:rPr sz="1150"/>
+                        <a:rPr sz="1100"/>
                         <a:t>3,567 km</a:t>
                       </a:r>
                     </a:p>
@@ -5180,8 +5180,8 @@
                         </a:spcAft>
                       </a:pPr>
                       <a:r>
-                        <a:rPr sz="1150"/>
-                        <a:t>82</a:t>
+                        <a:rPr sz="1100"/>
+                        <a:t>1,09,116 road-days of real weather</a:t>
                       </a:r>
                     </a:p>
                   </a:txBody>
@@ -5198,8 +5198,8 @@
                         </a:spcAft>
                       </a:pPr>
                       <a:r>
-                        <a:rPr sz="1150"/>
-                        <a:t>12</a:t>
+                        <a:rPr sz="1100"/>
+                        <a:t>0.88 (1.0 is perfect)</a:t>
                       </a:r>
                     </a:p>
                   </a:txBody>
@@ -5216,7 +5216,7 @@
                         </a:spcAft>
                       </a:pPr>
                       <a:r>
-                        <a:rPr sz="1150"/>
+                        <a:rPr sz="1100"/>
                         <a:t>4 apps and 1 dashboard</a:t>
                       </a:r>
                     </a:p>
@@ -5236,7 +5236,7 @@
         </p:nvSpPr>
         <p:spPr>
           <a:xfrm>
-            <a:off x="822960" y="2395728"/>
+            <a:off x="822960" y="2468880"/>
             <a:ext cx="5120640" cy="274320"/>
           </a:xfrm>
           <a:prstGeom prst="rect">
@@ -5270,7 +5270,7 @@
         </p:nvSpPr>
         <p:spPr>
           <a:xfrm>
-            <a:off x="822960" y="2724912"/>
+            <a:off x="822960" y="2798064"/>
             <a:ext cx="5120640" cy="2103120"/>
           </a:xfrm>
           <a:prstGeom prst="rect">
@@ -5291,7 +5291,7 @@
             </a:pPr>
             <a:r>
               <a:rPr sz="1100" b="0"/>
-              <a:t>The risk model marked the Dimapur to Kohima road as high risk after 161 mm of real rainfall. That road is Manipur's main supply line.</a:t>
+              <a:t>The forecast model was trained on two years of real recorded weather and tested only on later dates it had never seen. When it says 30%, the event happens about 30% of the time.</a:t>
             </a:r>
           </a:p>
           <a:p>
@@ -5302,7 +5302,7 @@
             </a:pPr>
             <a:r>
               <a:rPr sz="1100" b="0"/>
-              <a:t>As vehicle speeds dropped in a test, the road moved from open to slow to restricted to blocked, on its own.</a:t>
+              <a:t>As vehicle speeds dropped, one road moved from open to slow to blocked on its own, with no person involved, and the district alert followed.</a:t>
             </a:r>
           </a:p>
           <a:p>
@@ -5337,7 +5337,7 @@
         </p:nvSpPr>
         <p:spPr>
           <a:xfrm>
-            <a:off x="6309360" y="2395728"/>
+            <a:off x="6309360" y="2468880"/>
             <a:ext cx="5120640" cy="274320"/>
           </a:xfrm>
           <a:prstGeom prst="rect">
@@ -5371,7 +5371,7 @@
         </p:nvSpPr>
         <p:spPr>
           <a:xfrm>
-            <a:off x="6309360" y="2724912"/>
+            <a:off x="6309360" y="2798064"/>
             <a:ext cx="5120640" cy="2103120"/>
           </a:xfrm>
           <a:prstGeom prst="rect">

</xml_diff>

<commit_message>
Say all eight things that are actually novel, not just the sensor idea
Uniqueness listed three bullets, all of them the same point restated - the
carrier network is the sensing network. Everything else built into this
platform that a judge would count as innovation was somewhere else on the
deck as a feature, or nowhere at all.

It is now an eight-cell grid: carriers as sensors, no hardware or fleet,
voice reporting in ten languages that reads its understanding back before
filing, offline-first reports that queue under a client ID and are never
filed twice, forecasts that decompose into the feature that drove them, the
trust ladder where an unverified report can slow a road but never close one,
photo and GPS evidence on every incident, and a coverage panel that publishes
what the platform cannot see so a grey map never reads as a broken one.

The explanation above it drops to two paragraphs to make the room, and the
route flow on the right takes the recovered height.
</commit_message>
<xml_diff>
--- a/SIH2026_Sukobin.pptx
+++ b/SIH2026_Sukobin.pptx
@@ -6295,7 +6295,7 @@
         <p:spPr>
           <a:xfrm>
             <a:off x="411480" y="1435608"/>
-            <a:ext cx="6400800" cy="1572768"/>
+            <a:ext cx="6400800" cy="1188720"/>
           </a:xfrm>
           <a:prstGeom prst="rect">
             <a:avLst/>
@@ -6320,22 +6320,22 @@
               </a:spcAft>
             </a:pPr>
             <a:r>
-              <a:rPr sz="1100" b="1">
+              <a:rPr sz="1050" b="1">
                 <a:solidFill>
                   <a:srgbClr val="1F497D"/>
                 </a:solidFill>
                 <a:latin typeface="Arial"/>
               </a:rPr>
-              <a:t>Sukobin </a:t>
-            </a:r>
-            <a:r>
-              <a:rPr sz="1100" b="0">
+              <a:t>Nobody drives for us. </a:t>
+            </a:r>
+            <a:r>
+              <a:rPr sz="1050" b="0">
                 <a:solidFill>
                   <a:srgbClr val="262B33"/>
                 </a:solidFill>
                 <a:latin typeface="Arial"/>
               </a:rPr>
-              <a:t>combines GPS from registered transporters, field reports, weather and road-network data to understand how accessible a route is. Instead of costly roadside sensors, it turns vehicles already travelling the region into mobile road probes.</a:t>
+              <a:t>A driver declares a journey they were making anyway, and is offered only the consignments lying along that road, within capacity. Instead of costly roadside sensors, vehicles already travelling the region become mobile road probes.</a:t>
             </a:r>
           </a:p>
           <a:p>
@@ -6351,53 +6351,22 @@
               </a:spcAft>
             </a:pPr>
             <a:r>
-              <a:rPr sz="1100" b="1">
+              <a:rPr sz="1050" b="1">
                 <a:solidFill>
                   <a:srgbClr val="1F497D"/>
                 </a:solidFill>
                 <a:latin typeface="Arial"/>
               </a:rPr>
-              <a:t>Nobody drives for us. </a:t>
-            </a:r>
-            <a:r>
-              <a:rPr sz="1100" b="0">
+              <a:t>Their movement is the measurement. </a:t>
+            </a:r>
+            <a:r>
+              <a:rPr sz="1050" b="0">
                 <a:solidFill>
                   <a:srgbClr val="262B33"/>
                 </a:solidFill>
                 <a:latin typeface="Arial"/>
               </a:rPr>
-              <a:t>A driver declares a journey they were making anyway and is offered only the consignments lying along that road, within capacity.</a:t>
-            </a:r>
-          </a:p>
-          <a:p>
-            <a:pPr algn="l">
-              <a:lnSpc>
-                <a:spcPct val="100000"/>
-              </a:lnSpc>
-              <a:spcBef>
-                <a:spcPts val="700"/>
-              </a:spcBef>
-              <a:spcAft>
-                <a:spcPts val="0"/>
-              </a:spcAft>
-            </a:pPr>
-            <a:r>
-              <a:rPr sz="1100" b="1">
-                <a:solidFill>
-                  <a:srgbClr val="1F497D"/>
-                </a:solidFill>
-                <a:latin typeface="Arial"/>
-              </a:rPr>
-              <a:t>Their movement is the measurement. </a:t>
-            </a:r>
-            <a:r>
-              <a:rPr sz="1100" b="0">
-                <a:solidFill>
-                  <a:srgbClr val="262B33"/>
-                </a:solidFill>
-                <a:latin typeface="Arial"/>
-              </a:rPr>
-              <a:t>Median speed against each road's baseline gives live accessibility; AI turns it into risk, forecasts and alternate routes.</a:t>
+              <a:t>Median speed against each road's baseline gives live accessibility; AI turns it into risk scores, 72-hour forecasts, alerts and alternate routes.</a:t>
             </a:r>
           </a:p>
         </p:txBody>
@@ -6410,7 +6379,7 @@
         </p:nvSpPr>
         <p:spPr>
           <a:xfrm>
-            <a:off x="411480" y="3081528"/>
+            <a:off x="411480" y="2697480"/>
             <a:ext cx="6400800" cy="237744"/>
           </a:xfrm>
           <a:prstGeom prst="rect">
@@ -6455,7 +6424,7 @@
         </p:nvSpPr>
         <p:spPr>
           <a:xfrm>
-            <a:off x="411480" y="3268980"/>
+            <a:off x="411480" y="2884932"/>
             <a:ext cx="6400800" cy="12801"/>
           </a:xfrm>
           <a:prstGeom prst="rect">
@@ -6499,8 +6468,8 @@
         </p:nvSpPr>
         <p:spPr>
           <a:xfrm>
-            <a:off x="411480" y="3374136"/>
-            <a:ext cx="6400800" cy="1078992"/>
+            <a:off x="411480" y="2990088"/>
+            <a:ext cx="3136392" cy="365760"/>
           </a:xfrm>
           <a:prstGeom prst="roundRect">
             <a:avLst>
@@ -6532,106 +6501,680 @@
           </a:fontRef>
         </p:style>
         <p:txBody>
-          <a:bodyPr rtlCol="0" anchor="t" wrap="square" lIns="109728" rIns="109728" tIns="54864" bIns="54864"/>
+          <a:bodyPr rtlCol="0" anchor="t" wrap="square" lIns="109728" rIns="109728" tIns="27432" bIns="27432"/>
           <a:lstStyle/>
           <a:p>
             <a:pPr algn="l">
               <a:lnSpc>
-                <a:spcPct val="100000"/>
-              </a:lnSpc>
-              <a:spcBef>
-                <a:spcPts val="0"/>
-              </a:spcBef>
-              <a:spcAft>
-                <a:spcPts val="0"/>
-              </a:spcAft>
-            </a:pPr>
-            <a:r>
-              <a:rPr sz="1050" b="1">
+                <a:spcPct val="92000"/>
+              </a:lnSpc>
+              <a:spcBef>
+                <a:spcPts val="0"/>
+              </a:spcBef>
+              <a:spcAft>
+                <a:spcPts val="0"/>
+              </a:spcAft>
+            </a:pPr>
+            <a:r>
+              <a:rPr sz="900" b="1" i="0">
                 <a:solidFill>
                   <a:srgbClr val="1F497D"/>
                 </a:solidFill>
                 <a:latin typeface="Arial"/>
               </a:rPr>
-              <a:t>•  The carrier network IS the sensing network — </a:t>
-            </a:r>
-            <a:r>
-              <a:rPr sz="1050" b="0">
-                <a:solidFill>
-                  <a:srgbClr val="262B33"/>
-                </a:solidFill>
-                <a:latin typeface="Arial"/>
-              </a:rPr>
-              <a:t>one journey delivers goods and reads the road.</a:t>
+              <a:t>Carriers ARE the sensors</a:t>
             </a:r>
           </a:p>
           <a:p>
             <a:pPr algn="l">
               <a:lnSpc>
-                <a:spcPct val="100000"/>
-              </a:lnSpc>
-              <a:spcBef>
-                <a:spcPts val="700"/>
-              </a:spcBef>
-              <a:spcAft>
-                <a:spcPts val="0"/>
-              </a:spcAft>
-            </a:pPr>
-            <a:r>
-              <a:rPr sz="1050" b="1">
+                <a:spcPct val="92000"/>
+              </a:lnSpc>
+              <a:spcBef>
+                <a:spcPts val="100"/>
+              </a:spcBef>
+              <a:spcAft>
+                <a:spcPts val="0"/>
+              </a:spcAft>
+            </a:pPr>
+            <a:r>
+              <a:rPr sz="750" b="0" i="0">
+                <a:solidFill>
+                  <a:srgbClr val="5A636E"/>
+                </a:solidFill>
+                <a:latin typeface="Arial"/>
+              </a:rPr>
+              <a:t>one journey delivers goods and reads the road</a:t>
+            </a:r>
+          </a:p>
+        </p:txBody>
+      </p:sp>
+      <p:sp>
+        <p:nvSpPr>
+          <p:cNvPr id="15368" name="Rounded Rectangle 15367"/>
+          <p:cNvSpPr/>
+          <p:nvPr/>
+        </p:nvSpPr>
+        <p:spPr>
+          <a:xfrm>
+            <a:off x="3675888" y="2990088"/>
+            <a:ext cx="3136392" cy="365760"/>
+          </a:xfrm>
+          <a:prstGeom prst="roundRect">
+            <a:avLst>
+              <a:gd name="adj" fmla="val 8000"/>
+            </a:avLst>
+          </a:prstGeom>
+          <a:solidFill>
+            <a:srgbClr val="F2F5F9"/>
+          </a:solidFill>
+          <a:ln w="9525">
+            <a:solidFill>
+              <a:srgbClr val="C9D6E4"/>
+            </a:solidFill>
+          </a:ln>
+          <a:effectLst/>
+        </p:spPr>
+        <p:style>
+          <a:lnRef idx="1">
+            <a:schemeClr val="accent1"/>
+          </a:lnRef>
+          <a:fillRef idx="3">
+            <a:schemeClr val="accent1"/>
+          </a:fillRef>
+          <a:effectRef idx="2">
+            <a:schemeClr val="accent1"/>
+          </a:effectRef>
+          <a:fontRef idx="minor">
+            <a:schemeClr val="lt1"/>
+          </a:fontRef>
+        </p:style>
+        <p:txBody>
+          <a:bodyPr rtlCol="0" anchor="t" wrap="square" lIns="109728" rIns="109728" tIns="27432" bIns="27432"/>
+          <a:lstStyle/>
+          <a:p>
+            <a:pPr algn="l">
+              <a:lnSpc>
+                <a:spcPct val="92000"/>
+              </a:lnSpc>
+              <a:spcBef>
+                <a:spcPts val="0"/>
+              </a:spcBef>
+              <a:spcAft>
+                <a:spcPts val="0"/>
+              </a:spcAft>
+            </a:pPr>
+            <a:r>
+              <a:rPr sz="900" b="1" i="0">
                 <a:solidFill>
                   <a:srgbClr val="1F497D"/>
                 </a:solidFill>
                 <a:latin typeface="Arial"/>
               </a:rPr>
-              <a:t>•  No hardware, no dedicated fleet — </a:t>
-            </a:r>
-            <a:r>
-              <a:rPr sz="1050" b="0">
-                <a:solidFill>
-                  <a:srgbClr val="262B33"/>
-                </a:solidFill>
-                <a:latin typeface="Arial"/>
-              </a:rPr>
-              <a:t>nothing to install, power or maintain anywhere.</a:t>
+              <a:t>No hardware, no fleet</a:t>
             </a:r>
           </a:p>
           <a:p>
             <a:pPr algn="l">
               <a:lnSpc>
-                <a:spcPct val="100000"/>
-              </a:lnSpc>
-              <a:spcBef>
-                <a:spcPts val="700"/>
-              </a:spcBef>
-              <a:spcAft>
-                <a:spcPts val="0"/>
-              </a:spcAft>
-            </a:pPr>
-            <a:r>
-              <a:rPr sz="1050" b="1">
+                <a:spcPct val="92000"/>
+              </a:lnSpc>
+              <a:spcBef>
+                <a:spcPts val="100"/>
+              </a:spcBef>
+              <a:spcAft>
+                <a:spcPts val="0"/>
+              </a:spcAft>
+            </a:pPr>
+            <a:r>
+              <a:rPr sz="750" b="0" i="0">
+                <a:solidFill>
+                  <a:srgbClr val="5A636E"/>
+                </a:solidFill>
+                <a:latin typeface="Arial"/>
+              </a:rPr>
+              <a:t>nothing to install, power or maintain</a:t>
+            </a:r>
+          </a:p>
+        </p:txBody>
+      </p:sp>
+      <p:sp>
+        <p:nvSpPr>
+          <p:cNvPr id="15369" name="Rounded Rectangle 15368"/>
+          <p:cNvSpPr/>
+          <p:nvPr/>
+        </p:nvSpPr>
+        <p:spPr>
+          <a:xfrm>
+            <a:off x="411480" y="3410712"/>
+            <a:ext cx="3136392" cy="365760"/>
+          </a:xfrm>
+          <a:prstGeom prst="roundRect">
+            <a:avLst>
+              <a:gd name="adj" fmla="val 8000"/>
+            </a:avLst>
+          </a:prstGeom>
+          <a:solidFill>
+            <a:srgbClr val="F2F5F9"/>
+          </a:solidFill>
+          <a:ln w="9525">
+            <a:solidFill>
+              <a:srgbClr val="C9D6E4"/>
+            </a:solidFill>
+          </a:ln>
+          <a:effectLst/>
+        </p:spPr>
+        <p:style>
+          <a:lnRef idx="1">
+            <a:schemeClr val="accent1"/>
+          </a:lnRef>
+          <a:fillRef idx="3">
+            <a:schemeClr val="accent1"/>
+          </a:fillRef>
+          <a:effectRef idx="2">
+            <a:schemeClr val="accent1"/>
+          </a:effectRef>
+          <a:fontRef idx="minor">
+            <a:schemeClr val="lt1"/>
+          </a:fontRef>
+        </p:style>
+        <p:txBody>
+          <a:bodyPr rtlCol="0" anchor="t" wrap="square" lIns="109728" rIns="109728" tIns="27432" bIns="27432"/>
+          <a:lstStyle/>
+          <a:p>
+            <a:pPr algn="l">
+              <a:lnSpc>
+                <a:spcPct val="92000"/>
+              </a:lnSpc>
+              <a:spcBef>
+                <a:spcPts val="0"/>
+              </a:spcBef>
+              <a:spcAft>
+                <a:spcPts val="0"/>
+              </a:spcAft>
+            </a:pPr>
+            <a:r>
+              <a:rPr sz="900" b="1" i="0">
                 <a:solidFill>
                   <a:srgbClr val="1F497D"/>
                 </a:solidFill>
                 <a:latin typeface="Arial"/>
               </a:rPr>
-              <a:t>•  Self-improving — </a:t>
-            </a:r>
-            <a:r>
-              <a:rPr sz="1050" b="0">
-                <a:solidFill>
-                  <a:srgbClr val="262B33"/>
-                </a:solidFill>
-                <a:latin typeface="Arial"/>
-              </a:rPr>
-              <a:t>every new carrier adds sensing density at zero marginal cost.</a:t>
-            </a:r>
-          </a:p>
-        </p:txBody>
-      </p:sp>
-      <p:sp>
-        <p:nvSpPr>
-          <p:cNvPr id="15368" name="TextBox 15367"/>
+              <a:t>Voice reporting, 10 languages</a:t>
+            </a:r>
+          </a:p>
+          <a:p>
+            <a:pPr algn="l">
+              <a:lnSpc>
+                <a:spcPct val="92000"/>
+              </a:lnSpc>
+              <a:spcBef>
+                <a:spcPts val="100"/>
+              </a:spcBef>
+              <a:spcAft>
+                <a:spcPts val="0"/>
+              </a:spcAft>
+            </a:pPr>
+            <a:r>
+              <a:rPr sz="750" b="0" i="0">
+                <a:solidFill>
+                  <a:srgbClr val="5A636E"/>
+                </a:solidFill>
+                <a:latin typeface="Arial"/>
+              </a:rPr>
+              <a:t>speak it; the model classifies and reads it back</a:t>
+            </a:r>
+          </a:p>
+        </p:txBody>
+      </p:sp>
+      <p:sp>
+        <p:nvSpPr>
+          <p:cNvPr id="15370" name="Rounded Rectangle 15369"/>
+          <p:cNvSpPr/>
+          <p:nvPr/>
+        </p:nvSpPr>
+        <p:spPr>
+          <a:xfrm>
+            <a:off x="3675888" y="3410712"/>
+            <a:ext cx="3136392" cy="365760"/>
+          </a:xfrm>
+          <a:prstGeom prst="roundRect">
+            <a:avLst>
+              <a:gd name="adj" fmla="val 8000"/>
+            </a:avLst>
+          </a:prstGeom>
+          <a:solidFill>
+            <a:srgbClr val="F2F5F9"/>
+          </a:solidFill>
+          <a:ln w="9525">
+            <a:solidFill>
+              <a:srgbClr val="C9D6E4"/>
+            </a:solidFill>
+          </a:ln>
+          <a:effectLst/>
+        </p:spPr>
+        <p:style>
+          <a:lnRef idx="1">
+            <a:schemeClr val="accent1"/>
+          </a:lnRef>
+          <a:fillRef idx="3">
+            <a:schemeClr val="accent1"/>
+          </a:fillRef>
+          <a:effectRef idx="2">
+            <a:schemeClr val="accent1"/>
+          </a:effectRef>
+          <a:fontRef idx="minor">
+            <a:schemeClr val="lt1"/>
+          </a:fontRef>
+        </p:style>
+        <p:txBody>
+          <a:bodyPr rtlCol="0" anchor="t" wrap="square" lIns="109728" rIns="109728" tIns="27432" bIns="27432"/>
+          <a:lstStyle/>
+          <a:p>
+            <a:pPr algn="l">
+              <a:lnSpc>
+                <a:spcPct val="92000"/>
+              </a:lnSpc>
+              <a:spcBef>
+                <a:spcPts val="0"/>
+              </a:spcBef>
+              <a:spcAft>
+                <a:spcPts val="0"/>
+              </a:spcAft>
+            </a:pPr>
+            <a:r>
+              <a:rPr sz="900" b="1" i="0">
+                <a:solidFill>
+                  <a:srgbClr val="1F497D"/>
+                </a:solidFill>
+                <a:latin typeface="Arial"/>
+              </a:rPr>
+              <a:t>Offline-first field reports</a:t>
+            </a:r>
+          </a:p>
+          <a:p>
+            <a:pPr algn="l">
+              <a:lnSpc>
+                <a:spcPct val="92000"/>
+              </a:lnSpc>
+              <a:spcBef>
+                <a:spcPts val="100"/>
+              </a:spcBef>
+              <a:spcAft>
+                <a:spcPts val="0"/>
+              </a:spcAft>
+            </a:pPr>
+            <a:r>
+              <a:rPr sz="750" b="0" i="0">
+                <a:solidFill>
+                  <a:srgbClr val="5A636E"/>
+                </a:solidFill>
+                <a:latin typeface="Arial"/>
+              </a:rPr>
+              <a:t>queue on the phone, sync later, never filed twice</a:t>
+            </a:r>
+          </a:p>
+        </p:txBody>
+      </p:sp>
+      <p:sp>
+        <p:nvSpPr>
+          <p:cNvPr id="15371" name="Rounded Rectangle 15370"/>
+          <p:cNvSpPr/>
+          <p:nvPr/>
+        </p:nvSpPr>
+        <p:spPr>
+          <a:xfrm>
+            <a:off x="411480" y="3831336"/>
+            <a:ext cx="3136392" cy="365760"/>
+          </a:xfrm>
+          <a:prstGeom prst="roundRect">
+            <a:avLst>
+              <a:gd name="adj" fmla="val 8000"/>
+            </a:avLst>
+          </a:prstGeom>
+          <a:solidFill>
+            <a:srgbClr val="F2F5F9"/>
+          </a:solidFill>
+          <a:ln w="9525">
+            <a:solidFill>
+              <a:srgbClr val="C9D6E4"/>
+            </a:solidFill>
+          </a:ln>
+          <a:effectLst/>
+        </p:spPr>
+        <p:style>
+          <a:lnRef idx="1">
+            <a:schemeClr val="accent1"/>
+          </a:lnRef>
+          <a:fillRef idx="3">
+            <a:schemeClr val="accent1"/>
+          </a:fillRef>
+          <a:effectRef idx="2">
+            <a:schemeClr val="accent1"/>
+          </a:effectRef>
+          <a:fontRef idx="minor">
+            <a:schemeClr val="lt1"/>
+          </a:fontRef>
+        </p:style>
+        <p:txBody>
+          <a:bodyPr rtlCol="0" anchor="t" wrap="square" lIns="109728" rIns="109728" tIns="27432" bIns="27432"/>
+          <a:lstStyle/>
+          <a:p>
+            <a:pPr algn="l">
+              <a:lnSpc>
+                <a:spcPct val="92000"/>
+              </a:lnSpc>
+              <a:spcBef>
+                <a:spcPts val="0"/>
+              </a:spcBef>
+              <a:spcAft>
+                <a:spcPts val="0"/>
+              </a:spcAft>
+            </a:pPr>
+            <a:r>
+              <a:rPr sz="900" b="1" i="0">
+                <a:solidFill>
+                  <a:srgbClr val="1F497D"/>
+                </a:solidFill>
+                <a:latin typeface="Arial"/>
+              </a:rPr>
+              <a:t>Explainable forecasts</a:t>
+            </a:r>
+          </a:p>
+          <a:p>
+            <a:pPr algn="l">
+              <a:lnSpc>
+                <a:spcPct val="92000"/>
+              </a:lnSpc>
+              <a:spcBef>
+                <a:spcPts val="100"/>
+              </a:spcBef>
+              <a:spcAft>
+                <a:spcPts val="0"/>
+              </a:spcAft>
+            </a:pPr>
+            <a:r>
+              <a:rPr sz="750" b="0" i="0">
+                <a:solidFill>
+                  <a:srgbClr val="5A636E"/>
+                </a:solidFill>
+                <a:latin typeface="Arial"/>
+              </a:rPr>
+              <a:t>every number decomposes into the feature that drove it</a:t>
+            </a:r>
+          </a:p>
+        </p:txBody>
+      </p:sp>
+      <p:sp>
+        <p:nvSpPr>
+          <p:cNvPr id="15372" name="Rounded Rectangle 15371"/>
+          <p:cNvSpPr/>
+          <p:nvPr/>
+        </p:nvSpPr>
+        <p:spPr>
+          <a:xfrm>
+            <a:off x="3675888" y="3831336"/>
+            <a:ext cx="3136392" cy="365760"/>
+          </a:xfrm>
+          <a:prstGeom prst="roundRect">
+            <a:avLst>
+              <a:gd name="adj" fmla="val 8000"/>
+            </a:avLst>
+          </a:prstGeom>
+          <a:solidFill>
+            <a:srgbClr val="F2F5F9"/>
+          </a:solidFill>
+          <a:ln w="9525">
+            <a:solidFill>
+              <a:srgbClr val="C9D6E4"/>
+            </a:solidFill>
+          </a:ln>
+          <a:effectLst/>
+        </p:spPr>
+        <p:style>
+          <a:lnRef idx="1">
+            <a:schemeClr val="accent1"/>
+          </a:lnRef>
+          <a:fillRef idx="3">
+            <a:schemeClr val="accent1"/>
+          </a:fillRef>
+          <a:effectRef idx="2">
+            <a:schemeClr val="accent1"/>
+          </a:effectRef>
+          <a:fontRef idx="minor">
+            <a:schemeClr val="lt1"/>
+          </a:fontRef>
+        </p:style>
+        <p:txBody>
+          <a:bodyPr rtlCol="0" anchor="t" wrap="square" lIns="109728" rIns="109728" tIns="27432" bIns="27432"/>
+          <a:lstStyle/>
+          <a:p>
+            <a:pPr algn="l">
+              <a:lnSpc>
+                <a:spcPct val="92000"/>
+              </a:lnSpc>
+              <a:spcBef>
+                <a:spcPts val="0"/>
+              </a:spcBef>
+              <a:spcAft>
+                <a:spcPts val="0"/>
+              </a:spcAft>
+            </a:pPr>
+            <a:r>
+              <a:rPr sz="900" b="1" i="0">
+                <a:solidFill>
+                  <a:srgbClr val="1F497D"/>
+                </a:solidFill>
+                <a:latin typeface="Arial"/>
+              </a:rPr>
+              <a:t>A trust ladder</a:t>
+            </a:r>
+          </a:p>
+          <a:p>
+            <a:pPr algn="l">
+              <a:lnSpc>
+                <a:spcPct val="92000"/>
+              </a:lnSpc>
+              <a:spcBef>
+                <a:spcPts val="100"/>
+              </a:spcBef>
+              <a:spcAft>
+                <a:spcPts val="0"/>
+              </a:spcAft>
+            </a:pPr>
+            <a:r>
+              <a:rPr sz="750" b="0" i="0">
+                <a:solidFill>
+                  <a:srgbClr val="5A636E"/>
+                </a:solidFill>
+                <a:latin typeface="Arial"/>
+              </a:rPr>
+              <a:t>an unverified report can slow a road, never close one</a:t>
+            </a:r>
+          </a:p>
+        </p:txBody>
+      </p:sp>
+      <p:sp>
+        <p:nvSpPr>
+          <p:cNvPr id="15373" name="Rounded Rectangle 15372"/>
+          <p:cNvSpPr/>
+          <p:nvPr/>
+        </p:nvSpPr>
+        <p:spPr>
+          <a:xfrm>
+            <a:off x="411480" y="4251960"/>
+            <a:ext cx="3136392" cy="365760"/>
+          </a:xfrm>
+          <a:prstGeom prst="roundRect">
+            <a:avLst>
+              <a:gd name="adj" fmla="val 8000"/>
+            </a:avLst>
+          </a:prstGeom>
+          <a:solidFill>
+            <a:srgbClr val="F2F5F9"/>
+          </a:solidFill>
+          <a:ln w="9525">
+            <a:solidFill>
+              <a:srgbClr val="C9D6E4"/>
+            </a:solidFill>
+          </a:ln>
+          <a:effectLst/>
+        </p:spPr>
+        <p:style>
+          <a:lnRef idx="1">
+            <a:schemeClr val="accent1"/>
+          </a:lnRef>
+          <a:fillRef idx="3">
+            <a:schemeClr val="accent1"/>
+          </a:fillRef>
+          <a:effectRef idx="2">
+            <a:schemeClr val="accent1"/>
+          </a:effectRef>
+          <a:fontRef idx="minor">
+            <a:schemeClr val="lt1"/>
+          </a:fontRef>
+        </p:style>
+        <p:txBody>
+          <a:bodyPr rtlCol="0" anchor="t" wrap="square" lIns="109728" rIns="109728" tIns="27432" bIns="27432"/>
+          <a:lstStyle/>
+          <a:p>
+            <a:pPr algn="l">
+              <a:lnSpc>
+                <a:spcPct val="92000"/>
+              </a:lnSpc>
+              <a:spcBef>
+                <a:spcPts val="0"/>
+              </a:spcBef>
+              <a:spcAft>
+                <a:spcPts val="0"/>
+              </a:spcAft>
+            </a:pPr>
+            <a:r>
+              <a:rPr sz="900" b="1" i="0">
+                <a:solidFill>
+                  <a:srgbClr val="1F497D"/>
+                </a:solidFill>
+                <a:latin typeface="Arial"/>
+              </a:rPr>
+              <a:t>Photo + GPS evidence</a:t>
+            </a:r>
+          </a:p>
+          <a:p>
+            <a:pPr algn="l">
+              <a:lnSpc>
+                <a:spcPct val="92000"/>
+              </a:lnSpc>
+              <a:spcBef>
+                <a:spcPts val="100"/>
+              </a:spcBef>
+              <a:spcAft>
+                <a:spcPts val="0"/>
+              </a:spcAft>
+            </a:pPr>
+            <a:r>
+              <a:rPr sz="750" b="0" i="0">
+                <a:solidFill>
+                  <a:srgbClr val="5A636E"/>
+                </a:solidFill>
+                <a:latin typeface="Arial"/>
+              </a:rPr>
+              <a:t>every incident carries proof, not a phone call</a:t>
+            </a:r>
+          </a:p>
+        </p:txBody>
+      </p:sp>
+      <p:sp>
+        <p:nvSpPr>
+          <p:cNvPr id="15374" name="Rounded Rectangle 15373"/>
+          <p:cNvSpPr/>
+          <p:nvPr/>
+        </p:nvSpPr>
+        <p:spPr>
+          <a:xfrm>
+            <a:off x="3675888" y="4251960"/>
+            <a:ext cx="3136392" cy="365760"/>
+          </a:xfrm>
+          <a:prstGeom prst="roundRect">
+            <a:avLst>
+              <a:gd name="adj" fmla="val 8000"/>
+            </a:avLst>
+          </a:prstGeom>
+          <a:solidFill>
+            <a:srgbClr val="F2F5F9"/>
+          </a:solidFill>
+          <a:ln w="9525">
+            <a:solidFill>
+              <a:srgbClr val="C9D6E4"/>
+            </a:solidFill>
+          </a:ln>
+          <a:effectLst/>
+        </p:spPr>
+        <p:style>
+          <a:lnRef idx="1">
+            <a:schemeClr val="accent1"/>
+          </a:lnRef>
+          <a:fillRef idx="3">
+            <a:schemeClr val="accent1"/>
+          </a:fillRef>
+          <a:effectRef idx="2">
+            <a:schemeClr val="accent1"/>
+          </a:effectRef>
+          <a:fontRef idx="minor">
+            <a:schemeClr val="lt1"/>
+          </a:fontRef>
+        </p:style>
+        <p:txBody>
+          <a:bodyPr rtlCol="0" anchor="t" wrap="square" lIns="109728" rIns="109728" tIns="27432" bIns="27432"/>
+          <a:lstStyle/>
+          <a:p>
+            <a:pPr algn="l">
+              <a:lnSpc>
+                <a:spcPct val="92000"/>
+              </a:lnSpc>
+              <a:spcBef>
+                <a:spcPts val="0"/>
+              </a:spcBef>
+              <a:spcAft>
+                <a:spcPts val="0"/>
+              </a:spcAft>
+            </a:pPr>
+            <a:r>
+              <a:rPr sz="900" b="1" i="0">
+                <a:solidFill>
+                  <a:srgbClr val="1F497D"/>
+                </a:solidFill>
+                <a:latin typeface="Arial"/>
+              </a:rPr>
+              <a:t>It admits what it cannot see</a:t>
+            </a:r>
+          </a:p>
+          <a:p>
+            <a:pPr algn="l">
+              <a:lnSpc>
+                <a:spcPct val="92000"/>
+              </a:lnSpc>
+              <a:spcBef>
+                <a:spcPts val="100"/>
+              </a:spcBef>
+              <a:spcAft>
+                <a:spcPts val="0"/>
+              </a:spcAft>
+            </a:pPr>
+            <a:r>
+              <a:rPr sz="750" b="0" i="0">
+                <a:solidFill>
+                  <a:srgbClr val="5A636E"/>
+                </a:solidFill>
+                <a:latin typeface="Arial"/>
+              </a:rPr>
+              <a:t>coverage is published, so grey never looks like broken</a:t>
+            </a:r>
+          </a:p>
+        </p:txBody>
+      </p:sp>
+      <p:sp>
+        <p:nvSpPr>
+          <p:cNvPr id="15375" name="TextBox 15374"/>
           <p:cNvSpPr txBox="1"/>
           <p:nvPr/>
         </p:nvSpPr>
@@ -6676,14 +7219,14 @@
       </p:sp>
       <p:sp>
         <p:nvSpPr>
-          <p:cNvPr id="15369" name="Rounded Rectangle 15368"/>
+          <p:cNvPr id="15376" name="Rounded Rectangle 15375"/>
           <p:cNvSpPr/>
           <p:nvPr/>
         </p:nvSpPr>
         <p:spPr>
           <a:xfrm>
             <a:off x="7086600" y="1655064"/>
-            <a:ext cx="4690872" cy="438912"/>
+            <a:ext cx="4690872" cy="475488"/>
           </a:xfrm>
           <a:prstGeom prst="roundRect">
             <a:avLst>
@@ -6743,14 +7286,14 @@
       </p:sp>
       <p:sp>
         <p:nvSpPr>
-          <p:cNvPr id="15370" name="Down Arrow 15369"/>
+          <p:cNvPr id="15377" name="Down Arrow 15376"/>
           <p:cNvSpPr/>
           <p:nvPr/>
         </p:nvSpPr>
         <p:spPr>
           <a:xfrm>
-            <a:off x="9381744" y="2112264"/>
-            <a:ext cx="100584" cy="100583"/>
+            <a:off x="9381744" y="2148840"/>
+            <a:ext cx="100584" cy="118872"/>
           </a:xfrm>
           <a:prstGeom prst="downArrow">
             <a:avLst/>
@@ -6787,14 +7330,14 @@
       </p:sp>
       <p:sp>
         <p:nvSpPr>
-          <p:cNvPr id="15371" name="Rounded Rectangle 15370"/>
+          <p:cNvPr id="15378" name="Rounded Rectangle 15377"/>
           <p:cNvSpPr/>
           <p:nvPr/>
         </p:nvSpPr>
         <p:spPr>
           <a:xfrm>
-            <a:off x="7086600" y="2231136"/>
-            <a:ext cx="4690872" cy="438912"/>
+            <a:off x="7086600" y="2286000"/>
+            <a:ext cx="4690872" cy="475488"/>
           </a:xfrm>
           <a:prstGeom prst="roundRect">
             <a:avLst>
@@ -6854,14 +7397,14 @@
       </p:sp>
       <p:sp>
         <p:nvSpPr>
-          <p:cNvPr id="15372" name="Down Arrow 15371"/>
+          <p:cNvPr id="15379" name="Down Arrow 15378"/>
           <p:cNvSpPr/>
           <p:nvPr/>
         </p:nvSpPr>
         <p:spPr>
           <a:xfrm>
-            <a:off x="9381744" y="2688336"/>
-            <a:ext cx="100584" cy="100583"/>
+            <a:off x="9381744" y="2779776"/>
+            <a:ext cx="100584" cy="118872"/>
           </a:xfrm>
           <a:prstGeom prst="downArrow">
             <a:avLst/>
@@ -6898,14 +7441,14 @@
       </p:sp>
       <p:sp>
         <p:nvSpPr>
-          <p:cNvPr id="15373" name="Rounded Rectangle 15372"/>
+          <p:cNvPr id="15380" name="Rounded Rectangle 15379"/>
           <p:cNvSpPr/>
           <p:nvPr/>
         </p:nvSpPr>
         <p:spPr>
           <a:xfrm>
-            <a:off x="7086600" y="2807208"/>
-            <a:ext cx="4690872" cy="438912"/>
+            <a:off x="7086600" y="2916936"/>
+            <a:ext cx="4690872" cy="475488"/>
           </a:xfrm>
           <a:prstGeom prst="roundRect">
             <a:avLst>
@@ -6965,14 +7508,14 @@
       </p:sp>
       <p:sp>
         <p:nvSpPr>
-          <p:cNvPr id="15374" name="Down Arrow 15373"/>
+          <p:cNvPr id="15381" name="Down Arrow 15380"/>
           <p:cNvSpPr/>
           <p:nvPr/>
         </p:nvSpPr>
         <p:spPr>
           <a:xfrm>
-            <a:off x="9381744" y="3264408"/>
-            <a:ext cx="100584" cy="100583"/>
+            <a:off x="9381744" y="3410712"/>
+            <a:ext cx="100584" cy="118872"/>
           </a:xfrm>
           <a:prstGeom prst="downArrow">
             <a:avLst/>
@@ -7009,14 +7552,14 @@
       </p:sp>
       <p:sp>
         <p:nvSpPr>
-          <p:cNvPr id="15375" name="Rounded Rectangle 15374"/>
+          <p:cNvPr id="15382" name="Rounded Rectangle 15381"/>
           <p:cNvSpPr/>
           <p:nvPr/>
         </p:nvSpPr>
         <p:spPr>
           <a:xfrm>
-            <a:off x="7086600" y="3383279"/>
-            <a:ext cx="4690872" cy="438912"/>
+            <a:off x="7086600" y="3547872"/>
+            <a:ext cx="4690872" cy="475488"/>
           </a:xfrm>
           <a:prstGeom prst="roundRect">
             <a:avLst>
@@ -7076,14 +7619,14 @@
       </p:sp>
       <p:sp>
         <p:nvSpPr>
-          <p:cNvPr id="15376" name="Down Arrow 15375"/>
+          <p:cNvPr id="15383" name="Down Arrow 15382"/>
           <p:cNvSpPr/>
           <p:nvPr/>
         </p:nvSpPr>
         <p:spPr>
           <a:xfrm>
-            <a:off x="9381744" y="3840479"/>
-            <a:ext cx="100584" cy="100583"/>
+            <a:off x="9381744" y="4041648"/>
+            <a:ext cx="100584" cy="118872"/>
           </a:xfrm>
           <a:prstGeom prst="downArrow">
             <a:avLst/>
@@ -7120,14 +7663,14 @@
       </p:sp>
       <p:sp>
         <p:nvSpPr>
-          <p:cNvPr id="15377" name="Rounded Rectangle 15376"/>
+          <p:cNvPr id="15384" name="Rounded Rectangle 15383"/>
           <p:cNvSpPr/>
           <p:nvPr/>
         </p:nvSpPr>
         <p:spPr>
           <a:xfrm>
-            <a:off x="7086600" y="3959352"/>
-            <a:ext cx="4690872" cy="438912"/>
+            <a:off x="7086600" y="4178808"/>
+            <a:ext cx="4690872" cy="475488"/>
           </a:xfrm>
           <a:prstGeom prst="roundRect">
             <a:avLst>
@@ -7187,13 +7730,13 @@
       </p:sp>
       <p:sp>
         <p:nvSpPr>
-          <p:cNvPr id="15378" name="TextBox 15377"/>
+          <p:cNvPr id="15385" name="TextBox 15384"/>
           <p:cNvSpPr txBox="1"/>
           <p:nvPr/>
         </p:nvSpPr>
         <p:spPr>
           <a:xfrm>
-            <a:off x="411480" y="4562856"/>
+            <a:off x="411480" y="4764024"/>
             <a:ext cx="11365992" cy="237744"/>
           </a:xfrm>
           <a:prstGeom prst="rect">
@@ -7232,13 +7775,13 @@
       </p:sp>
       <p:sp>
         <p:nvSpPr>
-          <p:cNvPr id="15379" name="Rectangle 15378"/>
+          <p:cNvPr id="15386" name="Rectangle 15385"/>
           <p:cNvSpPr/>
           <p:nvPr/>
         </p:nvSpPr>
         <p:spPr>
           <a:xfrm>
-            <a:off x="411480" y="4750308"/>
+            <a:off x="411480" y="4951476"/>
             <a:ext cx="11365992" cy="12801"/>
           </a:xfrm>
           <a:prstGeom prst="rect">
@@ -7276,14 +7819,14 @@
       </p:sp>
       <p:sp>
         <p:nvSpPr>
-          <p:cNvPr id="15380" name="Rounded Rectangle 15379"/>
+          <p:cNvPr id="15387" name="Rounded Rectangle 15386"/>
           <p:cNvSpPr/>
           <p:nvPr/>
         </p:nvSpPr>
         <p:spPr>
           <a:xfrm>
-            <a:off x="411480" y="4855464"/>
-            <a:ext cx="2759202" cy="530352"/>
+            <a:off x="411480" y="5056632"/>
+            <a:ext cx="2759202" cy="502920"/>
           </a:xfrm>
           <a:prstGeom prst="roundRect">
             <a:avLst>
@@ -7374,14 +7917,14 @@
       </p:sp>
       <p:sp>
         <p:nvSpPr>
-          <p:cNvPr id="15381" name="Rounded Rectangle 15380"/>
+          <p:cNvPr id="15388" name="Rounded Rectangle 15387"/>
           <p:cNvSpPr/>
           <p:nvPr/>
         </p:nvSpPr>
         <p:spPr>
           <a:xfrm>
-            <a:off x="3280410" y="4855464"/>
-            <a:ext cx="2759202" cy="530352"/>
+            <a:off x="3280410" y="5056632"/>
+            <a:ext cx="2759202" cy="502920"/>
           </a:xfrm>
           <a:prstGeom prst="roundRect">
             <a:avLst>
@@ -7472,14 +8015,14 @@
       </p:sp>
       <p:sp>
         <p:nvSpPr>
-          <p:cNvPr id="15382" name="Rounded Rectangle 15381"/>
+          <p:cNvPr id="15389" name="Rounded Rectangle 15388"/>
           <p:cNvSpPr/>
           <p:nvPr/>
         </p:nvSpPr>
         <p:spPr>
           <a:xfrm>
-            <a:off x="6149340" y="4855464"/>
-            <a:ext cx="2759202" cy="530352"/>
+            <a:off x="6149340" y="5056632"/>
+            <a:ext cx="2759202" cy="502920"/>
           </a:xfrm>
           <a:prstGeom prst="roundRect">
             <a:avLst>
@@ -7570,14 +8113,14 @@
       </p:sp>
       <p:sp>
         <p:nvSpPr>
-          <p:cNvPr id="15383" name="Rounded Rectangle 15382"/>
+          <p:cNvPr id="15390" name="Rounded Rectangle 15389"/>
           <p:cNvSpPr/>
           <p:nvPr/>
         </p:nvSpPr>
         <p:spPr>
           <a:xfrm>
-            <a:off x="9018270" y="4855464"/>
-            <a:ext cx="2759202" cy="530352"/>
+            <a:off x="9018270" y="5056632"/>
+            <a:ext cx="2759202" cy="502920"/>
           </a:xfrm>
           <a:prstGeom prst="roundRect">
             <a:avLst>
@@ -7668,14 +8211,14 @@
       </p:sp>
       <p:sp>
         <p:nvSpPr>
-          <p:cNvPr id="15384" name="Rounded Rectangle 15383"/>
+          <p:cNvPr id="15391" name="Rounded Rectangle 15390"/>
           <p:cNvSpPr/>
           <p:nvPr/>
         </p:nvSpPr>
         <p:spPr>
           <a:xfrm>
-            <a:off x="411480" y="5458968"/>
-            <a:ext cx="2759202" cy="530352"/>
+            <a:off x="411480" y="5632704"/>
+            <a:ext cx="2759202" cy="502920"/>
           </a:xfrm>
           <a:prstGeom prst="roundRect">
             <a:avLst>
@@ -7766,14 +8309,14 @@
       </p:sp>
       <p:sp>
         <p:nvSpPr>
-          <p:cNvPr id="15385" name="Rounded Rectangle 15384"/>
+          <p:cNvPr id="15392" name="Rounded Rectangle 15391"/>
           <p:cNvSpPr/>
           <p:nvPr/>
         </p:nvSpPr>
         <p:spPr>
           <a:xfrm>
-            <a:off x="3280410" y="5458968"/>
-            <a:ext cx="2759202" cy="530352"/>
+            <a:off x="3280410" y="5632704"/>
+            <a:ext cx="2759202" cy="502920"/>
           </a:xfrm>
           <a:prstGeom prst="roundRect">
             <a:avLst>
@@ -7864,14 +8407,14 @@
       </p:sp>
       <p:sp>
         <p:nvSpPr>
-          <p:cNvPr id="15386" name="Rounded Rectangle 15385"/>
+          <p:cNvPr id="15393" name="Rounded Rectangle 15392"/>
           <p:cNvSpPr/>
           <p:nvPr/>
         </p:nvSpPr>
         <p:spPr>
           <a:xfrm>
-            <a:off x="6149340" y="5458968"/>
-            <a:ext cx="2759202" cy="530352"/>
+            <a:off x="6149340" y="5632704"/>
+            <a:ext cx="2759202" cy="502920"/>
           </a:xfrm>
           <a:prstGeom prst="roundRect">
             <a:avLst>
@@ -7962,14 +8505,14 @@
       </p:sp>
       <p:sp>
         <p:nvSpPr>
-          <p:cNvPr id="15387" name="Rounded Rectangle 15386"/>
+          <p:cNvPr id="15394" name="Rounded Rectangle 15393"/>
           <p:cNvSpPr/>
           <p:nvPr/>
         </p:nvSpPr>
         <p:spPr>
           <a:xfrm>
-            <a:off x="9018270" y="5458968"/>
-            <a:ext cx="2759202" cy="530352"/>
+            <a:off x="9018270" y="5632704"/>
+            <a:ext cx="2759202" cy="502920"/>
           </a:xfrm>
           <a:prstGeom prst="roundRect">
             <a:avLst>

</xml_diff>